<commit_message>
Clarify mid-project method and wording
</commit_message>
<xml_diff>
--- a/docs/MIDREPORT_public.pptx
+++ b/docs/MIDREPORT_public.pptx
@@ -3588,7 +3588,7 @@
                 </a:solidFill>
                 <a:latin typeface="Aptos"/>
               </a:rPr>
-              <a:t>01  METHOD + REPRODUCTION</a:t>
+              <a:t>WHAT WE ARE DOING</a:t>
             </a:r>
           </a:p>
         </p:txBody>
@@ -3602,7 +3602,7 @@
         <p:spPr>
           <a:xfrm>
             <a:off x="356616" y="1280160"/>
-            <a:ext cx="2743200" cy="1197864"/>
+            <a:ext cx="2743200" cy="1508760"/>
           </a:xfrm>
           <a:prstGeom prst="roundRect">
             <a:avLst>
@@ -3649,7 +3649,7 @@
         <p:spPr>
           <a:xfrm>
             <a:off x="356616" y="1280160"/>
-            <a:ext cx="41148" cy="1197864"/>
+            <a:ext cx="41148" cy="1508760"/>
           </a:xfrm>
           <a:prstGeom prst="rect">
             <a:avLst/>
@@ -3692,7 +3692,7 @@
         <p:spPr>
           <a:xfrm>
             <a:off x="475488" y="1371600"/>
-            <a:ext cx="2523744" cy="365760"/>
+            <a:ext cx="2523744" cy="621792"/>
           </a:xfrm>
           <a:prstGeom prst="rect">
             <a:avLst/>
@@ -3707,7 +3707,7 @@
           <a:p>
             <a:pPr algn="l">
               <a:lnSpc>
-                <a:spcPct val="102000"/>
+                <a:spcPct val="105000"/>
               </a:lnSpc>
               <a:spcBef>
                 <a:spcPts val="0"/>
@@ -3717,22 +3717,22 @@
               </a:spcAft>
             </a:pPr>
             <a:r>
-              <a:rPr sz="750" b="1" i="0">
-                <a:solidFill>
-                  <a:srgbClr val="9D1B32"/>
+              <a:rPr sz="750" b="0" i="0">
+                <a:solidFill>
+                  <a:srgbClr val="434952"/>
                 </a:solidFill>
                 <a:latin typeface="Aptos"/>
               </a:rPr>
-              <a:t>Research question</a:t>
-            </a:r>
-            <a:r>
-              <a:rPr sz="819" b="1" i="0">
+              <a:t>We rank every candidate link with Adamic–Adar, run PENCIL only on the top-k candidates, and vary PENCIL's sampled subgraph budget s. </a:t>
+            </a:r>
+            <a:r>
+              <a:rPr sz="750" b="1" i="0">
                 <a:solidFill>
                   <a:srgbClr val="171A1F"/>
                 </a:solidFill>
-                <a:latin typeface="Georgia"/>
+                <a:latin typeface="Aptos"/>
               </a:rPr>
-              <a:t>  Can a cheap graph heuristic decide where expensive PENCIL inference is worth paying for?</a:t>
+              <a:t>The (k, s) sweep measures how much accuracy remains at each GPU budget. The model is not retrained.</a:t>
             </a:r>
           </a:p>
         </p:txBody>
@@ -3745,7 +3745,7 @@
         </p:nvSpPr>
         <p:spPr>
           <a:xfrm>
-            <a:off x="466344" y="1837943"/>
+            <a:off x="466344" y="2121408"/>
             <a:ext cx="749808" cy="502920"/>
           </a:xfrm>
           <a:prstGeom prst="roundRect">
@@ -3792,7 +3792,7 @@
         </p:nvSpPr>
         <p:spPr>
           <a:xfrm>
-            <a:off x="512064" y="1892807"/>
+            <a:off x="512064" y="2176272"/>
             <a:ext cx="658368" cy="146304"/>
           </a:xfrm>
           <a:prstGeom prst="rect">
@@ -3837,7 +3837,7 @@
         </p:nvSpPr>
         <p:spPr>
           <a:xfrm>
-            <a:off x="493776" y="2112264"/>
+            <a:off x="493776" y="2395728"/>
             <a:ext cx="694944" cy="137160"/>
           </a:xfrm>
           <a:prstGeom prst="rect">
@@ -3882,7 +3882,7 @@
         </p:nvSpPr>
         <p:spPr>
           <a:xfrm>
-            <a:off x="1216152" y="1984248"/>
+            <a:off x="1216152" y="2267712"/>
             <a:ext cx="109728" cy="164592"/>
           </a:xfrm>
           <a:prstGeom prst="rect">
@@ -3927,7 +3927,7 @@
         </p:nvSpPr>
         <p:spPr>
           <a:xfrm>
-            <a:off x="1325880" y="1837943"/>
+            <a:off x="1325880" y="2121408"/>
             <a:ext cx="749808" cy="502920"/>
           </a:xfrm>
           <a:prstGeom prst="roundRect">
@@ -3974,7 +3974,7 @@
         </p:nvSpPr>
         <p:spPr>
           <a:xfrm>
-            <a:off x="1371600" y="1892807"/>
+            <a:off x="1371600" y="2176272"/>
             <a:ext cx="658368" cy="146304"/>
           </a:xfrm>
           <a:prstGeom prst="rect">
@@ -4019,7 +4019,7 @@
         </p:nvSpPr>
         <p:spPr>
           <a:xfrm>
-            <a:off x="1353312" y="2112264"/>
+            <a:off x="1353312" y="2395728"/>
             <a:ext cx="694944" cy="137160"/>
           </a:xfrm>
           <a:prstGeom prst="rect">
@@ -4064,7 +4064,7 @@
         </p:nvSpPr>
         <p:spPr>
           <a:xfrm>
-            <a:off x="2075688" y="1984248"/>
+            <a:off x="2075688" y="2267712"/>
             <a:ext cx="109728" cy="164592"/>
           </a:xfrm>
           <a:prstGeom prst="rect">
@@ -4109,7 +4109,7 @@
         </p:nvSpPr>
         <p:spPr>
           <a:xfrm>
-            <a:off x="2185415" y="1837943"/>
+            <a:off x="2185415" y="2121408"/>
             <a:ext cx="749808" cy="502920"/>
           </a:xfrm>
           <a:prstGeom prst="roundRect">
@@ -4156,7 +4156,7 @@
         </p:nvSpPr>
         <p:spPr>
           <a:xfrm>
-            <a:off x="2231135" y="1892807"/>
+            <a:off x="2231135" y="2176272"/>
             <a:ext cx="658368" cy="146304"/>
           </a:xfrm>
           <a:prstGeom prst="rect">
@@ -4201,7 +4201,7 @@
         </p:nvSpPr>
         <p:spPr>
           <a:xfrm>
-            <a:off x="2212847" y="2112264"/>
+            <a:off x="2212847" y="2395728"/>
             <a:ext cx="694944" cy="137160"/>
           </a:xfrm>
           <a:prstGeom prst="rect">
@@ -4246,7 +4246,7 @@
         </p:nvSpPr>
         <p:spPr>
           <a:xfrm>
-            <a:off x="356616" y="2615184"/>
+            <a:off x="356616" y="2926080"/>
             <a:ext cx="2743200" cy="164592"/>
           </a:xfrm>
           <a:prstGeom prst="rect">
@@ -4291,7 +4291,7 @@
         </p:nvSpPr>
         <p:spPr>
           <a:xfrm>
-            <a:off x="356616" y="2834640"/>
+            <a:off x="356616" y="3145536"/>
             <a:ext cx="841248" cy="749808"/>
           </a:xfrm>
           <a:prstGeom prst="roundRect">
@@ -4338,7 +4338,7 @@
         </p:nvSpPr>
         <p:spPr>
           <a:xfrm>
-            <a:off x="356616" y="2834640"/>
+            <a:off x="356616" y="3145536"/>
             <a:ext cx="841248" cy="36576"/>
           </a:xfrm>
           <a:prstGeom prst="rect">
@@ -4381,7 +4381,7 @@
         </p:nvSpPr>
         <p:spPr>
           <a:xfrm>
-            <a:off x="411480" y="2944368"/>
+            <a:off x="411480" y="3255264"/>
             <a:ext cx="731520" cy="228600"/>
           </a:xfrm>
           <a:prstGeom prst="rect">
@@ -4426,7 +4426,7 @@
         </p:nvSpPr>
         <p:spPr>
           <a:xfrm>
-            <a:off x="393192" y="3191256"/>
+            <a:off x="393192" y="3502152"/>
             <a:ext cx="768096" cy="128016"/>
           </a:xfrm>
           <a:prstGeom prst="rect">
@@ -4471,7 +4471,7 @@
         </p:nvSpPr>
         <p:spPr>
           <a:xfrm>
-            <a:off x="393192" y="3364992"/>
+            <a:off x="393192" y="3675887"/>
             <a:ext cx="768096" cy="118872"/>
           </a:xfrm>
           <a:prstGeom prst="rect">
@@ -4516,7 +4516,7 @@
         </p:nvSpPr>
         <p:spPr>
           <a:xfrm>
-            <a:off x="1280160" y="2834640"/>
+            <a:off x="1280160" y="3145536"/>
             <a:ext cx="841248" cy="749808"/>
           </a:xfrm>
           <a:prstGeom prst="roundRect">
@@ -4563,7 +4563,7 @@
         </p:nvSpPr>
         <p:spPr>
           <a:xfrm>
-            <a:off x="1280160" y="2834640"/>
+            <a:off x="1280160" y="3145536"/>
             <a:ext cx="841248" cy="36576"/>
           </a:xfrm>
           <a:prstGeom prst="rect">
@@ -4606,7 +4606,7 @@
         </p:nvSpPr>
         <p:spPr>
           <a:xfrm>
-            <a:off x="1335024" y="2944368"/>
+            <a:off x="1335024" y="3255264"/>
             <a:ext cx="731520" cy="228600"/>
           </a:xfrm>
           <a:prstGeom prst="rect">
@@ -4651,7 +4651,7 @@
         </p:nvSpPr>
         <p:spPr>
           <a:xfrm>
-            <a:off x="1316736" y="3191256"/>
+            <a:off x="1316736" y="3502152"/>
             <a:ext cx="768096" cy="128016"/>
           </a:xfrm>
           <a:prstGeom prst="rect">
@@ -4696,7 +4696,7 @@
         </p:nvSpPr>
         <p:spPr>
           <a:xfrm>
-            <a:off x="1316736" y="3364992"/>
+            <a:off x="1316736" y="3675887"/>
             <a:ext cx="768096" cy="118872"/>
           </a:xfrm>
           <a:prstGeom prst="rect">
@@ -4741,7 +4741,7 @@
         </p:nvSpPr>
         <p:spPr>
           <a:xfrm>
-            <a:off x="2203704" y="2834640"/>
+            <a:off x="2203704" y="3145536"/>
             <a:ext cx="841248" cy="749808"/>
           </a:xfrm>
           <a:prstGeom prst="roundRect">
@@ -4788,7 +4788,7 @@
         </p:nvSpPr>
         <p:spPr>
           <a:xfrm>
-            <a:off x="2203704" y="2834640"/>
+            <a:off x="2203704" y="3145536"/>
             <a:ext cx="841248" cy="36576"/>
           </a:xfrm>
           <a:prstGeom prst="rect">
@@ -4831,7 +4831,7 @@
         </p:nvSpPr>
         <p:spPr>
           <a:xfrm>
-            <a:off x="2258568" y="2944368"/>
+            <a:off x="2258568" y="3255264"/>
             <a:ext cx="731520" cy="228600"/>
           </a:xfrm>
           <a:prstGeom prst="rect">
@@ -4876,7 +4876,7 @@
         </p:nvSpPr>
         <p:spPr>
           <a:xfrm>
-            <a:off x="2240280" y="3191256"/>
+            <a:off x="2240280" y="3502152"/>
             <a:ext cx="768096" cy="128016"/>
           </a:xfrm>
           <a:prstGeom prst="rect">
@@ -4921,7 +4921,7 @@
         </p:nvSpPr>
         <p:spPr>
           <a:xfrm>
-            <a:off x="2240280" y="3364992"/>
+            <a:off x="2240280" y="3675887"/>
             <a:ext cx="768096" cy="118872"/>
           </a:xfrm>
           <a:prstGeom prst="rect">
@@ -4966,7 +4966,7 @@
         </p:nvSpPr>
         <p:spPr>
           <a:xfrm>
-            <a:off x="356616" y="3749039"/>
+            <a:off x="356616" y="4069080"/>
             <a:ext cx="2743200" cy="164592"/>
           </a:xfrm>
           <a:prstGeom prst="rect">
@@ -4998,7 +4998,7 @@
                 </a:solidFill>
                 <a:latin typeface="Aptos"/>
               </a:rPr>
-              <a:t>EXPERIMENTAL AUDIT</a:t>
+              <a:t>EXPERIMENT SETUP</a:t>
             </a:r>
           </a:p>
         </p:txBody>
@@ -5011,8 +5011,8 @@
         </p:nvSpPr>
         <p:spPr>
           <a:xfrm>
-            <a:off x="356616" y="3968496"/>
-            <a:ext cx="2743200" cy="1188720"/>
+            <a:off x="356616" y="4288536"/>
+            <a:ext cx="2743200" cy="1261872"/>
           </a:xfrm>
           <a:prstGeom prst="roundRect">
             <a:avLst>
@@ -5058,8 +5058,8 @@
         </p:nvSpPr>
         <p:spPr>
           <a:xfrm>
-            <a:off x="475488" y="4078224"/>
-            <a:ext cx="749808" cy="164592"/>
+            <a:off x="475488" y="4379976"/>
+            <a:ext cx="603504" cy="146304"/>
           </a:xfrm>
           <a:prstGeom prst="rect">
             <a:avLst/>
@@ -5090,7 +5090,7 @@
                 </a:solidFill>
                 <a:latin typeface="Aptos"/>
               </a:rPr>
-              <a:t>4 regimes</a:t>
+              <a:t>Data</a:t>
             </a:r>
           </a:p>
         </p:txBody>
@@ -5103,8 +5103,8 @@
         </p:nvSpPr>
         <p:spPr>
           <a:xfrm>
-            <a:off x="1197864" y="4078224"/>
-            <a:ext cx="1773936" cy="246888"/>
+            <a:off x="1078992" y="4379976"/>
+            <a:ext cx="1874519" cy="173736"/>
           </a:xfrm>
           <a:prstGeom prst="rect">
             <a:avLst/>
@@ -5129,13 +5129,13 @@
               </a:spcAft>
             </a:pPr>
             <a:r>
-              <a:rPr sz="645" b="0" i="0">
+              <a:rPr sz="655" b="0" i="0">
                 <a:solidFill>
                   <a:srgbClr val="434952"/>
                 </a:solidFill>
                 <a:latin typeface="Aptos"/>
               </a:rPr>
-              <a:t>Cora + Citeseer × shared-pool + HeaRT hard negatives</a:t>
+              <a:t>Cora and Citeseer</a:t>
             </a:r>
           </a:p>
         </p:txBody>
@@ -5148,7 +5148,7 @@
         </p:nvSpPr>
         <p:spPr>
           <a:xfrm>
-            <a:off x="466344" y="4361688"/>
+            <a:off x="466344" y="4613148"/>
             <a:ext cx="2523744" cy="7315"/>
           </a:xfrm>
           <a:prstGeom prst="rect">
@@ -5191,8 +5191,8 @@
         </p:nvSpPr>
         <p:spPr>
           <a:xfrm>
-            <a:off x="475488" y="4425696"/>
-            <a:ext cx="749808" cy="164592"/>
+            <a:off x="475488" y="4654296"/>
+            <a:ext cx="603504" cy="146304"/>
           </a:xfrm>
           <a:prstGeom prst="rect">
             <a:avLst/>
@@ -5223,7 +5223,7 @@
                 </a:solidFill>
                 <a:latin typeface="Aptos"/>
               </a:rPr>
-              <a:t>Validation only</a:t>
+              <a:t>Tests</a:t>
             </a:r>
           </a:p>
         </p:txBody>
@@ -5236,8 +5236,8 @@
         </p:nvSpPr>
         <p:spPr>
           <a:xfrm>
-            <a:off x="1197864" y="4425696"/>
-            <a:ext cx="1773936" cy="246888"/>
+            <a:off x="1078992" y="4654296"/>
+            <a:ext cx="1874519" cy="173736"/>
           </a:xfrm>
           <a:prstGeom prst="rect">
             <a:avLst/>
@@ -5262,13 +5262,13 @@
               </a:spcAft>
             </a:pPr>
             <a:r>
-              <a:rPr sz="645" b="0" i="0">
+              <a:rPr sz="655" b="0" i="0">
                 <a:solidFill>
                   <a:srgbClr val="434952"/>
                 </a:solidFill>
                 <a:latin typeface="Aptos"/>
               </a:rPr>
-              <a:t>select (k, s) under 5%, 10%, 25%, 50%, 75%, 100% caps</a:t>
+              <a:t>shared negative pool and HeaRT hard negatives</a:t>
             </a:r>
           </a:p>
         </p:txBody>
@@ -5281,7 +5281,7 @@
         </p:nvSpPr>
         <p:spPr>
           <a:xfrm>
-            <a:off x="466344" y="4709159"/>
+            <a:off x="466344" y="4887468"/>
             <a:ext cx="2523744" cy="7315"/>
           </a:xfrm>
           <a:prstGeom prst="rect">
@@ -5324,8 +5324,8 @@
         </p:nvSpPr>
         <p:spPr>
           <a:xfrm>
-            <a:off x="475488" y="4773168"/>
-            <a:ext cx="749808" cy="164592"/>
+            <a:off x="475488" y="4928616"/>
+            <a:ext cx="603504" cy="146304"/>
           </a:xfrm>
           <a:prstGeom prst="rect">
             <a:avLst/>
@@ -5356,7 +5356,7 @@
                 </a:solidFill>
                 <a:latin typeface="Aptos"/>
               </a:rPr>
-              <a:t>Bias checks</a:t>
+              <a:t>Selection</a:t>
             </a:r>
           </a:p>
         </p:txBody>
@@ -5369,8 +5369,8 @@
         </p:nvSpPr>
         <p:spPr>
           <a:xfrm>
-            <a:off x="1197864" y="4773168"/>
-            <a:ext cx="1773936" cy="246888"/>
+            <a:off x="1078992" y="4928616"/>
+            <a:ext cx="1874519" cy="173736"/>
           </a:xfrm>
           <a:prstGeom prst="rect">
             <a:avLst/>
@@ -5395,27 +5395,70 @@
               </a:spcAft>
             </a:pPr>
             <a:r>
-              <a:rPr sz="645" b="0" i="0">
+              <a:rPr sz="655" b="0" i="0">
                 <a:solidFill>
                   <a:srgbClr val="434952"/>
                 </a:solidFill>
                 <a:latin typeface="Aptos"/>
               </a:rPr>
-              <a:t>fixed float32 score collapse and shortlist tie-position bias</a:t>
-            </a:r>
-          </a:p>
-        </p:txBody>
-      </p:sp>
-      <p:sp>
-        <p:nvSpPr>
-          <p:cNvPr id="53" name="TextBox 52"/>
+              <a:t>choose (k, s) on validation under fixed compute caps</a:t>
+            </a:r>
+          </a:p>
+        </p:txBody>
+      </p:sp>
+      <p:sp>
+        <p:nvSpPr>
+          <p:cNvPr id="53" name="Rectangle 52"/>
+          <p:cNvSpPr/>
+          <p:nvPr/>
+        </p:nvSpPr>
+        <p:spPr>
+          <a:xfrm>
+            <a:off x="466344" y="5161788"/>
+            <a:ext cx="2523744" cy="7315"/>
+          </a:xfrm>
+          <a:prstGeom prst="rect">
+            <a:avLst/>
+          </a:prstGeom>
+          <a:solidFill>
+            <a:srgbClr val="D9D4CB"/>
+          </a:solidFill>
+          <a:ln>
+            <a:noFill/>
+          </a:ln>
+        </p:spPr>
+        <p:style>
+          <a:lnRef idx="1">
+            <a:schemeClr val="accent1"/>
+          </a:lnRef>
+          <a:fillRef idx="3">
+            <a:schemeClr val="accent1"/>
+          </a:fillRef>
+          <a:effectRef idx="2">
+            <a:schemeClr val="accent1"/>
+          </a:effectRef>
+          <a:fontRef idx="minor">
+            <a:schemeClr val="lt1"/>
+          </a:fontRef>
+        </p:style>
+        <p:txBody>
+          <a:bodyPr rtlCol="0" anchor="ctr"/>
+          <a:lstStyle/>
+          <a:p>
+            <a:pPr algn="ctr"/>
+          </a:p>
+        </p:txBody>
+      </p:sp>
+      <p:sp>
+        <p:nvSpPr>
+          <p:cNvPr id="54" name="TextBox 53"/>
           <p:cNvSpPr txBox="1"/>
           <p:nvPr/>
         </p:nvSpPr>
         <p:spPr>
           <a:xfrm>
-            <a:off x="356616" y="5330952"/>
-            <a:ext cx="2743200" cy="164592"/>
+            <a:off x="475488" y="5202936"/>
+            <a:ext cx="603504" cy="146304"/>
           </a:xfrm>
           <a:prstGeom prst="rect">
             <a:avLst/>
@@ -5440,27 +5483,117 @@
               </a:spcAft>
             </a:pPr>
             <a:r>
-              <a:rPr sz="819" b="1" i="0">
-                <a:solidFill>
-                  <a:srgbClr val="9D1B32"/>
+              <a:rPr sz="700" b="1" i="0">
+                <a:solidFill>
+                  <a:srgbClr val="203657"/>
                 </a:solidFill>
                 <a:latin typeface="Aptos"/>
               </a:rPr>
-              <a:t>ROAD TO FINAL SUBMISSION  ·  26 NOV</a:t>
-            </a:r>
-          </a:p>
-        </p:txBody>
-      </p:sp>
-      <p:sp>
-        <p:nvSpPr>
-          <p:cNvPr id="54" name="Rounded Rectangle 53"/>
+              <a:t>Checks</a:t>
+            </a:r>
+          </a:p>
+        </p:txBody>
+      </p:sp>
+      <p:sp>
+        <p:nvSpPr>
+          <p:cNvPr id="55" name="TextBox 54"/>
+          <p:cNvSpPr txBox="1"/>
+          <p:nvPr/>
+        </p:nvSpPr>
+        <p:spPr>
+          <a:xfrm>
+            <a:off x="1078992" y="5202936"/>
+            <a:ext cx="1874519" cy="173736"/>
+          </a:xfrm>
+          <a:prstGeom prst="rect">
+            <a:avLst/>
+          </a:prstGeom>
+          <a:noFill/>
+        </p:spPr>
+        <p:txBody>
+          <a:bodyPr wrap="square" lIns="0" rIns="0" tIns="0" bIns="0" anchor="t">
+            <a:spAutoFit/>
+          </a:bodyPr>
+          <a:lstStyle/>
+          <a:p>
+            <a:pPr algn="l">
+              <a:lnSpc>
+                <a:spcPct val="100000"/>
+              </a:lnSpc>
+              <a:spcBef>
+                <a:spcPts val="0"/>
+              </a:spcBef>
+              <a:spcAft>
+                <a:spcPts val="0"/>
+              </a:spcAft>
+            </a:pPr>
+            <a:r>
+              <a:rPr sz="655" b="0" i="0">
+                <a:solidFill>
+                  <a:srgbClr val="434952"/>
+                </a:solidFill>
+                <a:latin typeface="Aptos"/>
+              </a:rPr>
+              <a:t>corrected score-precision and shortlist tie bias</a:t>
+            </a:r>
+          </a:p>
+        </p:txBody>
+      </p:sp>
+      <p:sp>
+        <p:nvSpPr>
+          <p:cNvPr id="56" name="TextBox 55"/>
+          <p:cNvSpPr txBox="1"/>
+          <p:nvPr/>
+        </p:nvSpPr>
+        <p:spPr>
+          <a:xfrm>
+            <a:off x="356616" y="5733288"/>
+            <a:ext cx="2743200" cy="164592"/>
+          </a:xfrm>
+          <a:prstGeom prst="rect">
+            <a:avLst/>
+          </a:prstGeom>
+          <a:noFill/>
+        </p:spPr>
+        <p:txBody>
+          <a:bodyPr wrap="square" lIns="0" rIns="0" tIns="0" bIns="0" anchor="t">
+            <a:spAutoFit/>
+          </a:bodyPr>
+          <a:lstStyle/>
+          <a:p>
+            <a:pPr algn="l">
+              <a:lnSpc>
+                <a:spcPct val="100000"/>
+              </a:lnSpc>
+              <a:spcBef>
+                <a:spcPts val="0"/>
+              </a:spcBef>
+              <a:spcAft>
+                <a:spcPts val="0"/>
+              </a:spcAft>
+            </a:pPr>
+            <a:r>
+              <a:rPr sz="819" b="1" i="0">
+                <a:solidFill>
+                  <a:srgbClr val="9D1B32"/>
+                </a:solidFill>
+                <a:latin typeface="Aptos"/>
+              </a:rPr>
+              <a:t>WHAT WE MEASURE</a:t>
+            </a:r>
+          </a:p>
+        </p:txBody>
+      </p:sp>
+      <p:sp>
+        <p:nvSpPr>
+          <p:cNvPr id="57" name="Rounded Rectangle 56"/>
           <p:cNvSpPr/>
           <p:nvPr/>
         </p:nvSpPr>
         <p:spPr>
           <a:xfrm>
-            <a:off x="356616" y="5550408"/>
-            <a:ext cx="2743200" cy="850392"/>
+            <a:off x="356616" y="5952744"/>
+            <a:ext cx="2743200" cy="448056"/>
           </a:xfrm>
           <a:prstGeom prst="roundRect">
             <a:avLst>
@@ -5500,14 +5633,14 @@
       </p:sp>
       <p:sp>
         <p:nvSpPr>
-          <p:cNvPr id="55" name="TextBox 54"/>
+          <p:cNvPr id="58" name="TextBox 57"/>
           <p:cNvSpPr txBox="1"/>
           <p:nvPr/>
         </p:nvSpPr>
         <p:spPr>
           <a:xfrm>
-            <a:off x="475488" y="5650992"/>
-            <a:ext cx="2505456" cy="640080"/>
+            <a:off x="475488" y="6062472"/>
+            <a:ext cx="2505456" cy="201168"/>
           </a:xfrm>
           <a:prstGeom prst="rect">
             <a:avLst/>
@@ -5520,72 +5653,32 @@
           </a:bodyPr>
           <a:lstStyle/>
           <a:p>
-            <a:pPr algn="l">
+            <a:pPr algn="ctr">
               <a:lnSpc>
-                <a:spcPct val="102000"/>
+                <a:spcPct val="100000"/>
               </a:lnSpc>
               <a:spcBef>
                 <a:spcPts val="0"/>
               </a:spcBef>
               <a:spcAft>
-                <a:spcPts val="300"/>
+                <a:spcPts val="0"/>
               </a:spcAft>
             </a:pPr>
             <a:r>
-              <a:rPr sz="720" b="1" i="0">
-                <a:solidFill>
-                  <a:srgbClr val="B46318"/>
+              <a:rPr sz="680" b="1" i="0">
+                <a:solidFill>
+                  <a:srgbClr val="434952"/>
                 </a:solidFill>
                 <a:latin typeface="Aptos"/>
               </a:rPr>
-              <a:t>1  Training law</a:t>
-            </a:r>
-            <a:r>
-              <a:rPr sz="680" b="0" i="0">
-                <a:solidFill>
-                  <a:srgbClr val="434952"/>
-                </a:solidFill>
-                <a:latin typeface="Aptos"/>
-              </a:rPr>
-              <a:t>  93% of final Cora MRR is reached by epoch 42/150.</a:t>
-            </a:r>
-          </a:p>
-          <a:p>
-            <a:pPr algn="l">
-              <a:lnSpc>
-                <a:spcPct val="102000"/>
-              </a:lnSpc>
-              <a:spcBef>
-                <a:spcPts val="0"/>
-              </a:spcBef>
-              <a:spcAft>
-                <a:spcPts val="0"/>
-              </a:spcAft>
-            </a:pPr>
-            <a:r>
-              <a:rPr sz="720" b="1" i="0">
-                <a:solidFill>
-                  <a:srgbClr val="B46318"/>
-                </a:solidFill>
-                <a:latin typeface="Aptos"/>
-              </a:rPr>
-              <a:t>2  Deliverables</a:t>
-            </a:r>
-            <a:r>
-              <a:rPr sz="680" b="0" i="0">
-                <a:solidFill>
-                  <a:srgbClr val="434952"/>
-                </a:solidFill>
-                <a:latin typeface="Aptos"/>
-              </a:rPr>
-              <a:t>  closed-form selector · latency/VRAM Pareto · final report · PPT video · reproducible code.</a:t>
-            </a:r>
-          </a:p>
-        </p:txBody>
-      </p:sp>
-      <p:sp>
-        <p:nvSpPr>
-          <p:cNvPr id="56" name="TextBox 55"/>
+              <a:t>Test MRR ×100  ·  measured T4 GPU time  ·  peak VRAM  ·  three random seeds per budget</a:t>
+            </a:r>
+          </a:p>
+        </p:txBody>
+      </p:sp>
+      <p:sp>
+        <p:nvSpPr>
+          <p:cNvPr id="59" name="TextBox 58"/>
           <p:cNvSpPr txBox="1"/>
           <p:nvPr/>
         </p:nvSpPr>
@@ -5623,14 +5716,14 @@
                 </a:solidFill>
                 <a:latin typeface="Aptos"/>
               </a:rPr>
-              <a:t>02  FOUR EMPIRICAL COMPUTE-ALLOCATION LAWS</a:t>
-            </a:r>
-          </a:p>
-        </p:txBody>
-      </p:sp>
-      <p:sp>
-        <p:nvSpPr>
-          <p:cNvPr id="57" name="Rounded Rectangle 56"/>
+              <a:t>RESULTS FROM THE BUDGET SWEEP</a:t>
+            </a:r>
+          </a:p>
+        </p:txBody>
+      </p:sp>
+      <p:sp>
+        <p:nvSpPr>
+          <p:cNvPr id="60" name="Rounded Rectangle 59"/>
           <p:cNvSpPr/>
           <p:nvPr/>
         </p:nvSpPr>
@@ -5677,7 +5770,7 @@
       </p:sp>
       <p:sp>
         <p:nvSpPr>
-          <p:cNvPr id="58" name="Rectangle 57"/>
+          <p:cNvPr id="61" name="Rectangle 60"/>
           <p:cNvSpPr/>
           <p:nvPr/>
         </p:nvSpPr>
@@ -5720,7 +5813,7 @@
       </p:sp>
       <p:sp>
         <p:nvSpPr>
-          <p:cNvPr id="59" name="Oval 58"/>
+          <p:cNvPr id="62" name="Oval 61"/>
           <p:cNvSpPr/>
           <p:nvPr/>
         </p:nvSpPr>
@@ -5765,7 +5858,7 @@
       </p:sp>
       <p:sp>
         <p:nvSpPr>
-          <p:cNvPr id="60" name="TextBox 59"/>
+          <p:cNvPr id="63" name="TextBox 62"/>
           <p:cNvSpPr txBox="1"/>
           <p:nvPr/>
         </p:nvSpPr>
@@ -5810,7 +5903,7 @@
       </p:sp>
       <p:sp>
         <p:nvSpPr>
-          <p:cNvPr id="61" name="TextBox 60"/>
+          <p:cNvPr id="64" name="TextBox 63"/>
           <p:cNvSpPr txBox="1"/>
           <p:nvPr/>
         </p:nvSpPr>
@@ -5855,7 +5948,7 @@
       </p:sp>
       <p:sp>
         <p:nvSpPr>
-          <p:cNvPr id="62" name="TextBox 61"/>
+          <p:cNvPr id="65" name="TextBox 64"/>
           <p:cNvSpPr txBox="1"/>
           <p:nvPr/>
         </p:nvSpPr>
@@ -5900,7 +5993,7 @@
       </p:sp>
       <p:sp>
         <p:nvSpPr>
-          <p:cNvPr id="63" name="Rounded Rectangle 62"/>
+          <p:cNvPr id="66" name="Rounded Rectangle 65"/>
           <p:cNvSpPr/>
           <p:nvPr/>
         </p:nvSpPr>
@@ -5947,7 +6040,7 @@
       </p:sp>
       <p:sp>
         <p:nvSpPr>
-          <p:cNvPr id="64" name="Rectangle 63"/>
+          <p:cNvPr id="67" name="Rectangle 66"/>
           <p:cNvSpPr/>
           <p:nvPr/>
         </p:nvSpPr>
@@ -5990,7 +6083,7 @@
       </p:sp>
       <p:sp>
         <p:nvSpPr>
-          <p:cNvPr id="65" name="Oval 64"/>
+          <p:cNvPr id="68" name="Oval 67"/>
           <p:cNvSpPr/>
           <p:nvPr/>
         </p:nvSpPr>
@@ -6035,7 +6128,7 @@
       </p:sp>
       <p:sp>
         <p:nvSpPr>
-          <p:cNvPr id="66" name="TextBox 65"/>
+          <p:cNvPr id="69" name="TextBox 68"/>
           <p:cNvSpPr txBox="1"/>
           <p:nvPr/>
         </p:nvSpPr>
@@ -6080,7 +6173,7 @@
       </p:sp>
       <p:sp>
         <p:nvSpPr>
-          <p:cNvPr id="67" name="TextBox 66"/>
+          <p:cNvPr id="70" name="TextBox 69"/>
           <p:cNvSpPr txBox="1"/>
           <p:nvPr/>
         </p:nvSpPr>
@@ -6125,7 +6218,7 @@
       </p:sp>
       <p:sp>
         <p:nvSpPr>
-          <p:cNvPr id="68" name="TextBox 67"/>
+          <p:cNvPr id="71" name="TextBox 70"/>
           <p:cNvSpPr txBox="1"/>
           <p:nvPr/>
         </p:nvSpPr>
@@ -6170,7 +6263,7 @@
       </p:sp>
       <p:sp>
         <p:nvSpPr>
-          <p:cNvPr id="69" name="Rounded Rectangle 68"/>
+          <p:cNvPr id="72" name="Rounded Rectangle 71"/>
           <p:cNvSpPr/>
           <p:nvPr/>
         </p:nvSpPr>
@@ -6217,7 +6310,7 @@
       </p:sp>
       <p:sp>
         <p:nvSpPr>
-          <p:cNvPr id="70" name="Rectangle 69"/>
+          <p:cNvPr id="73" name="Rectangle 72"/>
           <p:cNvSpPr/>
           <p:nvPr/>
         </p:nvSpPr>
@@ -6260,7 +6353,7 @@
       </p:sp>
       <p:sp>
         <p:nvSpPr>
-          <p:cNvPr id="71" name="Oval 70"/>
+          <p:cNvPr id="74" name="Oval 73"/>
           <p:cNvSpPr/>
           <p:nvPr/>
         </p:nvSpPr>
@@ -6305,7 +6398,7 @@
       </p:sp>
       <p:sp>
         <p:nvSpPr>
-          <p:cNvPr id="72" name="TextBox 71"/>
+          <p:cNvPr id="75" name="TextBox 74"/>
           <p:cNvSpPr txBox="1"/>
           <p:nvPr/>
         </p:nvSpPr>
@@ -6350,7 +6443,7 @@
       </p:sp>
       <p:sp>
         <p:nvSpPr>
-          <p:cNvPr id="73" name="TextBox 72"/>
+          <p:cNvPr id="76" name="TextBox 75"/>
           <p:cNvSpPr txBox="1"/>
           <p:nvPr/>
         </p:nvSpPr>
@@ -6395,7 +6488,7 @@
       </p:sp>
       <p:sp>
         <p:nvSpPr>
-          <p:cNvPr id="74" name="TextBox 73"/>
+          <p:cNvPr id="77" name="TextBox 76"/>
           <p:cNvSpPr txBox="1"/>
           <p:nvPr/>
         </p:nvSpPr>
@@ -6440,7 +6533,7 @@
       </p:sp>
       <p:sp>
         <p:nvSpPr>
-          <p:cNvPr id="75" name="Rounded Rectangle 74"/>
+          <p:cNvPr id="78" name="Rounded Rectangle 77"/>
           <p:cNvSpPr/>
           <p:nvPr/>
         </p:nvSpPr>
@@ -6487,7 +6580,7 @@
       </p:sp>
       <p:sp>
         <p:nvSpPr>
-          <p:cNvPr id="76" name="Rectangle 75"/>
+          <p:cNvPr id="79" name="Rectangle 78"/>
           <p:cNvSpPr/>
           <p:nvPr/>
         </p:nvSpPr>
@@ -6530,7 +6623,7 @@
       </p:sp>
       <p:sp>
         <p:nvSpPr>
-          <p:cNvPr id="77" name="Oval 76"/>
+          <p:cNvPr id="80" name="Oval 79"/>
           <p:cNvSpPr/>
           <p:nvPr/>
         </p:nvSpPr>
@@ -6575,7 +6668,7 @@
       </p:sp>
       <p:sp>
         <p:nvSpPr>
-          <p:cNvPr id="78" name="TextBox 77"/>
+          <p:cNvPr id="81" name="TextBox 80"/>
           <p:cNvSpPr txBox="1"/>
           <p:nvPr/>
         </p:nvSpPr>
@@ -6620,7 +6713,7 @@
       </p:sp>
       <p:sp>
         <p:nvSpPr>
-          <p:cNvPr id="79" name="TextBox 78"/>
+          <p:cNvPr id="82" name="TextBox 81"/>
           <p:cNvSpPr txBox="1"/>
           <p:nvPr/>
         </p:nvSpPr>
@@ -6665,7 +6758,7 @@
       </p:sp>
       <p:sp>
         <p:nvSpPr>
-          <p:cNvPr id="80" name="TextBox 79"/>
+          <p:cNvPr id="83" name="TextBox 82"/>
           <p:cNvSpPr txBox="1"/>
           <p:nvPr/>
         </p:nvSpPr>
@@ -6710,7 +6803,7 @@
       </p:sp>
       <p:sp>
         <p:nvSpPr>
-          <p:cNvPr id="81" name="Rounded Rectangle 80"/>
+          <p:cNvPr id="84" name="Rounded Rectangle 83"/>
           <p:cNvSpPr/>
           <p:nvPr/>
         </p:nvSpPr>
@@ -6755,7 +6848,7 @@
       </p:sp>
       <p:sp>
         <p:nvSpPr>
-          <p:cNvPr id="82" name="TextBox 81"/>
+          <p:cNvPr id="85" name="TextBox 84"/>
           <p:cNvSpPr txBox="1"/>
           <p:nvPr/>
         </p:nvSpPr>
@@ -6793,7 +6886,7 @@
                 </a:solidFill>
                 <a:latin typeface="Aptos"/>
               </a:rPr>
-              <a:t>INTERIM LAW  </a:t>
+              <a:t>Main result: </a:t>
             </a:r>
             <a:r>
               <a:rPr sz="760" b="1" i="0">
@@ -6802,14 +6895,14 @@
                 </a:solidFill>
                 <a:latin typeface="Aptos"/>
               </a:rPr>
-              <a:t>reduce fanout first; reserve full context for the hard regime.</a:t>
-            </a:r>
-          </a:p>
-        </p:txBody>
-      </p:sp>
-      <p:sp>
-        <p:nvSpPr>
-          <p:cNvPr id="83" name="TextBox 82"/>
+              <a:t>reducing fanout is usually safer than shortening the candidate list.</a:t>
+            </a:r>
+          </a:p>
+        </p:txBody>
+      </p:sp>
+      <p:sp>
+        <p:nvSpPr>
+          <p:cNvPr id="86" name="TextBox 85"/>
           <p:cNvSpPr txBox="1"/>
           <p:nvPr/>
         </p:nvSpPr>
@@ -6847,14 +6940,14 @@
                 </a:solidFill>
                 <a:latin typeface="Aptos"/>
               </a:rPr>
-              <a:t>03  EVIDENCE ACROSS FOUR TEST REGIMES</a:t>
-            </a:r>
-          </a:p>
-        </p:txBody>
-      </p:sp>
-      <p:sp>
-        <p:nvSpPr>
-          <p:cNvPr id="84" name="Rounded Rectangle 83"/>
+              <a:t>BUDGET SWEEPS</a:t>
+            </a:r>
+          </a:p>
+        </p:txBody>
+      </p:sp>
+      <p:sp>
+        <p:nvSpPr>
+          <p:cNvPr id="87" name="Rounded Rectangle 86"/>
           <p:cNvSpPr/>
           <p:nvPr/>
         </p:nvSpPr>
@@ -6901,7 +6994,7 @@
       </p:sp>
       <p:pic>
         <p:nvPicPr>
-          <p:cNvPr id="85" name="Picture 84" descr="fig_mid.png"/>
+          <p:cNvPr id="88" name="Picture 87" descr="fig_mid.png"/>
           <p:cNvPicPr>
             <a:picLocks noChangeAspect="1"/>
           </p:cNvPicPr>
@@ -6925,7 +7018,7 @@
       </p:pic>
       <p:sp>
         <p:nvSpPr>
-          <p:cNvPr id="86" name="TextBox 85"/>
+          <p:cNvPr id="89" name="TextBox 88"/>
           <p:cNvSpPr txBox="1"/>
           <p:nvPr/>
         </p:nvSpPr>
@@ -6970,7 +7063,7 @@
       </p:sp>
       <p:sp>
         <p:nvSpPr>
-          <p:cNvPr id="87" name="TextBox 86"/>
+          <p:cNvPr id="90" name="TextBox 89"/>
           <p:cNvSpPr txBox="1"/>
           <p:nvPr/>
         </p:nvSpPr>
@@ -7015,7 +7108,7 @@
       </p:sp>
       <p:sp>
         <p:nvSpPr>
-          <p:cNvPr id="88" name="Rectangle 87"/>
+          <p:cNvPr id="91" name="Rectangle 90"/>
           <p:cNvSpPr/>
           <p:nvPr/>
         </p:nvSpPr>
@@ -7058,7 +7151,7 @@
       </p:sp>
       <p:sp>
         <p:nvSpPr>
-          <p:cNvPr id="89" name="TextBox 88"/>
+          <p:cNvPr id="92" name="TextBox 91"/>
           <p:cNvSpPr txBox="1"/>
           <p:nvPr/>
         </p:nvSpPr>
@@ -7103,7 +7196,7 @@
       </p:sp>
       <p:sp>
         <p:nvSpPr>
-          <p:cNvPr id="90" name="TextBox 89"/>
+          <p:cNvPr id="93" name="TextBox 92"/>
           <p:cNvSpPr txBox="1"/>
           <p:nvPr/>
         </p:nvSpPr>
@@ -7149,7 +7242,7 @@
       </p:sp>
       <p:sp>
         <p:nvSpPr>
-          <p:cNvPr id="91" name="TextBox 90"/>
+          <p:cNvPr id="94" name="TextBox 93"/>
           <p:cNvSpPr txBox="1"/>
           <p:nvPr/>
         </p:nvSpPr>
@@ -7195,7 +7288,7 @@
       </p:sp>
       <p:sp>
         <p:nvSpPr>
-          <p:cNvPr id="92" name="TextBox 91"/>
+          <p:cNvPr id="95" name="TextBox 94"/>
           <p:cNvSpPr txBox="1"/>
           <p:nvPr/>
         </p:nvSpPr>
@@ -7241,7 +7334,7 @@
       </p:sp>
       <p:sp>
         <p:nvSpPr>
-          <p:cNvPr id="93" name="TextBox 92"/>
+          <p:cNvPr id="96" name="TextBox 95"/>
           <p:cNvSpPr txBox="1"/>
           <p:nvPr/>
         </p:nvSpPr>
@@ -7287,7 +7380,7 @@
       </p:sp>
       <p:sp>
         <p:nvSpPr>
-          <p:cNvPr id="94" name="Rectangle 93"/>
+          <p:cNvPr id="97" name="Rectangle 96"/>
           <p:cNvSpPr/>
           <p:nvPr/>
         </p:nvSpPr>
@@ -7330,7 +7423,7 @@
       </p:sp>
       <p:sp>
         <p:nvSpPr>
-          <p:cNvPr id="95" name="Rectangle 94"/>
+          <p:cNvPr id="98" name="Rectangle 97"/>
           <p:cNvSpPr/>
           <p:nvPr/>
         </p:nvSpPr>
@@ -7373,7 +7466,7 @@
       </p:sp>
       <p:sp>
         <p:nvSpPr>
-          <p:cNvPr id="96" name="TextBox 95"/>
+          <p:cNvPr id="99" name="TextBox 98"/>
           <p:cNvSpPr txBox="1"/>
           <p:nvPr/>
         </p:nvSpPr>
@@ -7418,7 +7511,7 @@
       </p:sp>
       <p:sp>
         <p:nvSpPr>
-          <p:cNvPr id="97" name="TextBox 96"/>
+          <p:cNvPr id="100" name="TextBox 99"/>
           <p:cNvSpPr txBox="1"/>
           <p:nvPr/>
         </p:nvSpPr>
@@ -7463,7 +7556,7 @@
       </p:sp>
       <p:sp>
         <p:nvSpPr>
-          <p:cNvPr id="98" name="TextBox 97"/>
+          <p:cNvPr id="101" name="TextBox 100"/>
           <p:cNvSpPr txBox="1"/>
           <p:nvPr/>
         </p:nvSpPr>
@@ -7508,7 +7601,7 @@
       </p:sp>
       <p:sp>
         <p:nvSpPr>
-          <p:cNvPr id="99" name="TextBox 98"/>
+          <p:cNvPr id="102" name="TextBox 101"/>
           <p:cNvSpPr txBox="1"/>
           <p:nvPr/>
         </p:nvSpPr>
@@ -7553,7 +7646,7 @@
       </p:sp>
       <p:sp>
         <p:nvSpPr>
-          <p:cNvPr id="100" name="TextBox 99"/>
+          <p:cNvPr id="103" name="TextBox 102"/>
           <p:cNvSpPr txBox="1"/>
           <p:nvPr/>
         </p:nvSpPr>
@@ -7598,7 +7691,7 @@
       </p:sp>
       <p:sp>
         <p:nvSpPr>
-          <p:cNvPr id="101" name="Rectangle 100"/>
+          <p:cNvPr id="104" name="Rectangle 103"/>
           <p:cNvSpPr/>
           <p:nvPr/>
         </p:nvSpPr>
@@ -7641,7 +7734,7 @@
       </p:sp>
       <p:sp>
         <p:nvSpPr>
-          <p:cNvPr id="102" name="Rectangle 101"/>
+          <p:cNvPr id="105" name="Rectangle 104"/>
           <p:cNvSpPr/>
           <p:nvPr/>
         </p:nvSpPr>
@@ -7684,7 +7777,7 @@
       </p:sp>
       <p:sp>
         <p:nvSpPr>
-          <p:cNvPr id="103" name="TextBox 102"/>
+          <p:cNvPr id="106" name="TextBox 105"/>
           <p:cNvSpPr txBox="1"/>
           <p:nvPr/>
         </p:nvSpPr>
@@ -7729,7 +7822,7 @@
       </p:sp>
       <p:sp>
         <p:nvSpPr>
-          <p:cNvPr id="104" name="TextBox 103"/>
+          <p:cNvPr id="107" name="TextBox 106"/>
           <p:cNvSpPr txBox="1"/>
           <p:nvPr/>
         </p:nvSpPr>
@@ -7774,7 +7867,7 @@
       </p:sp>
       <p:sp>
         <p:nvSpPr>
-          <p:cNvPr id="105" name="TextBox 104"/>
+          <p:cNvPr id="108" name="TextBox 107"/>
           <p:cNvSpPr txBox="1"/>
           <p:nvPr/>
         </p:nvSpPr>
@@ -7819,7 +7912,7 @@
       </p:sp>
       <p:sp>
         <p:nvSpPr>
-          <p:cNvPr id="106" name="TextBox 105"/>
+          <p:cNvPr id="109" name="TextBox 108"/>
           <p:cNvSpPr txBox="1"/>
           <p:nvPr/>
         </p:nvSpPr>
@@ -7864,7 +7957,7 @@
       </p:sp>
       <p:sp>
         <p:nvSpPr>
-          <p:cNvPr id="107" name="TextBox 106"/>
+          <p:cNvPr id="110" name="TextBox 109"/>
           <p:cNvSpPr txBox="1"/>
           <p:nvPr/>
         </p:nvSpPr>
@@ -7909,7 +8002,7 @@
       </p:sp>
       <p:sp>
         <p:nvSpPr>
-          <p:cNvPr id="108" name="Rectangle 107"/>
+          <p:cNvPr id="111" name="Rectangle 110"/>
           <p:cNvSpPr/>
           <p:nvPr/>
         </p:nvSpPr>
@@ -7952,7 +8045,7 @@
       </p:sp>
       <p:sp>
         <p:nvSpPr>
-          <p:cNvPr id="109" name="Rectangle 108"/>
+          <p:cNvPr id="112" name="Rectangle 111"/>
           <p:cNvSpPr/>
           <p:nvPr/>
         </p:nvSpPr>
@@ -7995,7 +8088,7 @@
       </p:sp>
       <p:sp>
         <p:nvSpPr>
-          <p:cNvPr id="110" name="TextBox 109"/>
+          <p:cNvPr id="113" name="TextBox 112"/>
           <p:cNvSpPr txBox="1"/>
           <p:nvPr/>
         </p:nvSpPr>
@@ -8040,7 +8133,7 @@
       </p:sp>
       <p:sp>
         <p:nvSpPr>
-          <p:cNvPr id="111" name="TextBox 110"/>
+          <p:cNvPr id="114" name="TextBox 113"/>
           <p:cNvSpPr txBox="1"/>
           <p:nvPr/>
         </p:nvSpPr>
@@ -8085,7 +8178,7 @@
       </p:sp>
       <p:sp>
         <p:nvSpPr>
-          <p:cNvPr id="112" name="TextBox 111"/>
+          <p:cNvPr id="115" name="TextBox 114"/>
           <p:cNvSpPr txBox="1"/>
           <p:nvPr/>
         </p:nvSpPr>
@@ -8130,7 +8223,7 @@
       </p:sp>
       <p:sp>
         <p:nvSpPr>
-          <p:cNvPr id="113" name="TextBox 112"/>
+          <p:cNvPr id="116" name="TextBox 115"/>
           <p:cNvSpPr txBox="1"/>
           <p:nvPr/>
         </p:nvSpPr>
@@ -8175,7 +8268,7 @@
       </p:sp>
       <p:sp>
         <p:nvSpPr>
-          <p:cNvPr id="114" name="TextBox 113"/>
+          <p:cNvPr id="117" name="TextBox 116"/>
           <p:cNvSpPr txBox="1"/>
           <p:nvPr/>
         </p:nvSpPr>
@@ -8220,7 +8313,7 @@
       </p:sp>
       <p:sp>
         <p:nvSpPr>
-          <p:cNvPr id="115" name="Rectangle 114"/>
+          <p:cNvPr id="118" name="Rectangle 117"/>
           <p:cNvSpPr/>
           <p:nvPr/>
         </p:nvSpPr>
@@ -8263,7 +8356,7 @@
       </p:sp>
       <p:sp>
         <p:nvSpPr>
-          <p:cNvPr id="116" name="Rectangle 115"/>
+          <p:cNvPr id="119" name="Rectangle 118"/>
           <p:cNvSpPr/>
           <p:nvPr/>
         </p:nvSpPr>
@@ -8306,7 +8399,7 @@
       </p:sp>
       <p:sp>
         <p:nvSpPr>
-          <p:cNvPr id="117" name="TextBox 116"/>
+          <p:cNvPr id="120" name="TextBox 119"/>
           <p:cNvSpPr txBox="1"/>
           <p:nvPr/>
         </p:nvSpPr>
@@ -8351,7 +8444,7 @@
       </p:sp>
       <p:sp>
         <p:nvSpPr>
-          <p:cNvPr id="118" name="TextBox 117"/>
+          <p:cNvPr id="121" name="TextBox 120"/>
           <p:cNvSpPr txBox="1"/>
           <p:nvPr/>
         </p:nvSpPr>
@@ -8396,7 +8489,7 @@
       </p:sp>
       <p:sp>
         <p:nvSpPr>
-          <p:cNvPr id="119" name="TextBox 118"/>
+          <p:cNvPr id="122" name="TextBox 121"/>
           <p:cNvSpPr txBox="1"/>
           <p:nvPr/>
         </p:nvSpPr>
@@ -8441,7 +8534,7 @@
       </p:sp>
       <p:sp>
         <p:nvSpPr>
-          <p:cNvPr id="120" name="TextBox 119"/>
+          <p:cNvPr id="123" name="TextBox 122"/>
           <p:cNvSpPr txBox="1"/>
           <p:nvPr/>
         </p:nvSpPr>
@@ -8486,7 +8579,7 @@
       </p:sp>
       <p:sp>
         <p:nvSpPr>
-          <p:cNvPr id="121" name="TextBox 120"/>
+          <p:cNvPr id="124" name="TextBox 123"/>
           <p:cNvSpPr txBox="1"/>
           <p:nvPr/>
         </p:nvSpPr>
@@ -8531,7 +8624,7 @@
       </p:sp>
       <p:sp>
         <p:nvSpPr>
-          <p:cNvPr id="122" name="Rectangle 121"/>
+          <p:cNvPr id="125" name="Rectangle 124"/>
           <p:cNvSpPr/>
           <p:nvPr/>
         </p:nvSpPr>
@@ -8574,7 +8667,7 @@
       </p:sp>
       <p:sp>
         <p:nvSpPr>
-          <p:cNvPr id="123" name="Rectangle 122"/>
+          <p:cNvPr id="126" name="Rectangle 125"/>
           <p:cNvSpPr/>
           <p:nvPr/>
         </p:nvSpPr>
@@ -8617,7 +8710,7 @@
       </p:sp>
       <p:sp>
         <p:nvSpPr>
-          <p:cNvPr id="124" name="TextBox 123"/>
+          <p:cNvPr id="127" name="TextBox 126"/>
           <p:cNvSpPr txBox="1"/>
           <p:nvPr/>
         </p:nvSpPr>
@@ -8662,7 +8755,7 @@
       </p:sp>
       <p:sp>
         <p:nvSpPr>
-          <p:cNvPr id="125" name="TextBox 124"/>
+          <p:cNvPr id="128" name="TextBox 127"/>
           <p:cNvSpPr txBox="1"/>
           <p:nvPr/>
         </p:nvSpPr>
@@ -8707,7 +8800,7 @@
       </p:sp>
       <p:sp>
         <p:nvSpPr>
-          <p:cNvPr id="126" name="TextBox 125"/>
+          <p:cNvPr id="129" name="TextBox 128"/>
           <p:cNvSpPr txBox="1"/>
           <p:nvPr/>
         </p:nvSpPr>
@@ -8752,7 +8845,7 @@
       </p:sp>
       <p:sp>
         <p:nvSpPr>
-          <p:cNvPr id="127" name="TextBox 126"/>
+          <p:cNvPr id="130" name="TextBox 129"/>
           <p:cNvSpPr txBox="1"/>
           <p:nvPr/>
         </p:nvSpPr>
@@ -8797,7 +8890,7 @@
       </p:sp>
       <p:sp>
         <p:nvSpPr>
-          <p:cNvPr id="128" name="TextBox 127"/>
+          <p:cNvPr id="131" name="TextBox 130"/>
           <p:cNvSpPr txBox="1"/>
           <p:nvPr/>
         </p:nvSpPr>
@@ -8842,7 +8935,7 @@
       </p:sp>
       <p:sp>
         <p:nvSpPr>
-          <p:cNvPr id="129" name="Rectangle 128"/>
+          <p:cNvPr id="132" name="Rectangle 131"/>
           <p:cNvSpPr/>
           <p:nvPr/>
         </p:nvSpPr>
@@ -8885,7 +8978,7 @@
       </p:sp>
       <p:sp>
         <p:nvSpPr>
-          <p:cNvPr id="130" name="TextBox 129"/>
+          <p:cNvPr id="133" name="TextBox 132"/>
           <p:cNvSpPr txBox="1"/>
           <p:nvPr/>
         </p:nvSpPr>
@@ -8923,14 +9016,14 @@
                 </a:solidFill>
                 <a:latin typeface="Aptos"/>
               </a:rPr>
-              <a:t>TRANSFER + RESOURCE EVIDENCE</a:t>
-            </a:r>
-          </a:p>
-        </p:txBody>
-      </p:sp>
-      <p:sp>
-        <p:nvSpPr>
-          <p:cNvPr id="131" name="Rounded Rectangle 130"/>
+              <a:t>ADDITIONAL RESULTS</a:t>
+            </a:r>
+          </a:p>
+        </p:txBody>
+      </p:sp>
+      <p:sp>
+        <p:nvSpPr>
+          <p:cNvPr id="134" name="Rounded Rectangle 133"/>
           <p:cNvSpPr/>
           <p:nvPr/>
         </p:nvSpPr>
@@ -8977,7 +9070,7 @@
       </p:sp>
       <p:sp>
         <p:nvSpPr>
-          <p:cNvPr id="132" name="Rectangle 131"/>
+          <p:cNvPr id="135" name="Rectangle 134"/>
           <p:cNvSpPr/>
           <p:nvPr/>
         </p:nvSpPr>
@@ -9020,7 +9113,7 @@
       </p:sp>
       <p:sp>
         <p:nvSpPr>
-          <p:cNvPr id="133" name="TextBox 132"/>
+          <p:cNvPr id="136" name="TextBox 135"/>
           <p:cNvSpPr txBox="1"/>
           <p:nvPr/>
         </p:nvSpPr>
@@ -9074,7 +9167,7 @@
       </p:sp>
       <p:sp>
         <p:nvSpPr>
-          <p:cNvPr id="134" name="Rectangle 133"/>
+          <p:cNvPr id="137" name="Rectangle 136"/>
           <p:cNvSpPr/>
           <p:nvPr/>
         </p:nvSpPr>
@@ -9117,7 +9210,7 @@
       </p:sp>
       <p:sp>
         <p:nvSpPr>
-          <p:cNvPr id="135" name="TextBox 134"/>
+          <p:cNvPr id="138" name="TextBox 137"/>
           <p:cNvSpPr txBox="1"/>
           <p:nvPr/>
         </p:nvSpPr>
@@ -9171,7 +9264,7 @@
       </p:sp>
       <p:sp>
         <p:nvSpPr>
-          <p:cNvPr id="136" name="Rectangle 135"/>
+          <p:cNvPr id="139" name="Rectangle 138"/>
           <p:cNvSpPr/>
           <p:nvPr/>
         </p:nvSpPr>
@@ -9214,7 +9307,7 @@
       </p:sp>
       <p:sp>
         <p:nvSpPr>
-          <p:cNvPr id="137" name="TextBox 136"/>
+          <p:cNvPr id="140" name="TextBox 139"/>
           <p:cNvSpPr txBox="1"/>
           <p:nvPr/>
         </p:nvSpPr>
@@ -9246,13 +9339,13 @@
               </a:spcAft>
             </a:pPr>
             <a:r>
-              <a:rPr sz="640" b="1" i="0">
+              <a:rPr sz="650" b="1" i="0">
                 <a:solidFill>
                   <a:srgbClr val="777D85"/>
                 </a:solidFill>
-                <a:latin typeface="Consolas"/>
+                <a:latin typeface="Aptos"/>
               </a:rPr>
-              <a:t>Reproducible code + 112 score dumps: github.com/Ask-812/da4022-pencil-budget</a:t>
+              <a:t>All operating points are selected on validation data; test data are used only for the reported results.</a:t>
             </a:r>
           </a:p>
         </p:txBody>

</xml_diff>